<commit_message>
Make Task 2 data model slide an explicit ERD
Title it as an ERD, link each FK row to its PK row with non-crossing
right-angle connectors, mark 1 and n on every relationship, and update
the notes, presenting script and README to match.

Co-Authored-By: Claude Opus 5.5 <noreply@anthropic.com>
Claude-Session: https://claude.ai/code/session_01Nd7HZKgsHFz3NCndSJLPaG
</commit_message>
<xml_diff>
--- a/bai_tap_python_nhom8/task2_tran_phuc_hoang/2431540018_TranPhucHoang.pptx
+++ b/bai_tap_python_nhom8/task2_tran_phuc_hoang/2431540018_TranPhucHoang.pptx
@@ -116,27 +116,27 @@
   <p:extLst>
     <p:ext uri="{521415D9-36F7-43E2-AB2F-B90AF26B5E84}">
       <p14:sectionLst xmlns:p14="http://schemas.microsoft.com/office/powerpoint/2010/main">
-        <p14:section name="Mở đầu" id="{239faeef-0374-eb87-cf77-a885fabbb189}">
+        <p14:section name="Mở đầu" id="{738746d1-a3a1-0dff-7207-85bad1651c69}">
           <p14:sldIdLst>
             <p14:sldId id="256"/>
             <p14:sldId id="257"/>
           </p14:sldIdLst>
         </p14:section>
-        <p14:section name="Chuẩn hóa dữ liệu" id="{9fd66873-10ba-6ca3-6f3d-e4e9f64c2dbe}">
+        <p14:section name="Chuẩn hóa dữ liệu" id="{987e8be1-8579-f428-99b3-3c9a01d304cf}">
           <p14:sldIdLst>
             <p14:sldId id="258"/>
             <p14:sldId id="259"/>
             <p14:sldId id="260"/>
           </p14:sldIdLst>
         </p14:section>
-        <p14:section name="Mô hình kho dữ liệu" id="{fe053237-66b5-e526-bbf7-67511e75acae}">
+        <p14:section name="Mô hình kho dữ liệu" id="{80c6aa58-f64a-0f8e-1fd9-8b6df576dfed}">
           <p14:sldIdLst>
             <p14:sldId id="261"/>
             <p14:sldId id="262"/>
             <p14:sldId id="263"/>
           </p14:sldIdLst>
         </p14:section>
-        <p14:section name="Kết quả &amp; tổng kết" id="{821782f4-55d6-dfbc-d742-160e85b2f972}">
+        <p14:section name="Kết quả &amp; tổng kết" id="{7b63ae4e-ff35-ded2-adde-e75229f98026}">
           <p14:sldIdLst>
             <p14:sldId id="264"/>
             <p14:sldId id="265"/>
@@ -1079,7 +1079,7 @@
           <a:p>
             <a:r>
               <a:rPr lang="en-US" dirty="0"/>
-              <a:t>Em chia dữ liệu tuyển dụng thành 5 nhóm thông tin như đề bài gợi ý: ứng viên, vị trí, nguồn, vòng phỏng vấn và trạng thái. Cả 5 nhóm gặp nhau ở hồ sơ ứng tuyển: mỗi hồ sơ cho biết ai nộp, nộp vị trí nào, từ nguồn nào, đang ở vòng nào và kết quả ra sao.</a:t>
+              <a:t>Em chia dữ liệu tuyển dụng thành 5 nhóm thông tin như đề bài gợi ý: ứng viên, vị trí, nguồn, vòng phỏng vấn và trạng thái. Cả 5 nhóm gặp nhau ở hồ sơ ứng tuyển: mỗi hồ sơ cho biết ai nộp, nộp vị trí nào, từ nguồn nào, đang ở vòng nào và kết quả ra sao. Năm nhóm này sẽ trở thành các bảng (thực thể) trong sơ đồ ERD ở slide 7.</a:t>
             </a:r>
             <a:endParaRPr lang="en-US" dirty="0"/>
           </a:p>
@@ -1431,7 +1431,7 @@
           <a:p>
             <a:r>
               <a:rPr lang="en-US" dirty="0"/>
-              <a:t>Đây là mô hình kho dữ liệu gồm 6 bảng: bảng ho_so_ung_tuyen ở giữa, mỗi dòng là một lần nộp hồ sơ. Các cột FK chỉ lưu mã số và nối sang 5 bảng thông tin xung quanh. Ví dụ một ứng viên có thể nộp nhiều vị trí, nên một ứng viên nối với nhiều hồ sơ.</a:t>
+              <a:t>Đây là sơ đồ ERD, tức sơ đồ thực thể – quan hệ, của kho dữ liệu 6 bảng: bảng ho_so_ung_tuyen ở giữa, mỗi dòng là một lần nộp hồ sơ. Mỗi đường nối đi từ cột FK của bảng chính tới cột PK của một bảng xung quanh, số 1 và n cho biết quan hệ một – nhiều. Ví dụ một ứng viên có thể nộp nhiều vị trí, nên một ứng viên nối với nhiều hồ sơ.</a:t>
             </a:r>
             <a:endParaRPr lang="en-US" dirty="0"/>
           </a:p>
@@ -11854,7 +11854,7 @@
                 <a:ea typeface="Cambria" pitchFamily="34" charset="-122"/>
                 <a:cs typeface="Cambria" pitchFamily="34" charset="-120"/>
               </a:rPr>
-              <a:t>Mô hình kho dữ liệu: 6 bảng</a:t>
+              <a:t>Sơ đồ ERD: kho dữ liệu 6 bảng</a:t>
             </a:r>
             <a:endParaRPr lang="en-US" sz="3200" dirty="0"/>
           </a:p>
@@ -11862,14 +11862,14 @@
       </p:sp>
       <p:sp>
         <p:nvSpPr>
-          <p:cNvPr id="3" name="Link ung_vien"/>
+          <p:cNvPr id="3" name="Link ung_vien a"/>
           <p:cNvSpPr/>
           <p:nvPr/>
         </p:nvSpPr>
         <p:spPr>
           <a:xfrm>
-            <a:off x="3383280" y="2112264"/>
-            <a:ext cx="868680" cy="201168"/>
+            <a:off x="3383280" y="1933956"/>
+            <a:ext cx="411480" cy="0"/>
           </a:xfrm>
           <a:prstGeom prst="line">
             <a:avLst/>
@@ -11885,14 +11885,14 @@
       </p:sp>
       <p:sp>
         <p:nvSpPr>
-          <p:cNvPr id="4" name="Link vi_tri"/>
+          <p:cNvPr id="4" name="Link ung_vien b"/>
           <p:cNvSpPr/>
           <p:nvPr/>
         </p:nvSpPr>
         <p:spPr>
-          <a:xfrm flipV="1">
-            <a:off x="3383280" y="2587752"/>
-            <a:ext cx="868680" cy="1092708"/>
+          <a:xfrm>
+            <a:off x="3794760" y="1933956"/>
+            <a:ext cx="0" cy="379476"/>
           </a:xfrm>
           <a:prstGeom prst="line">
             <a:avLst/>
@@ -11908,14 +11908,14 @@
       </p:sp>
       <p:sp>
         <p:nvSpPr>
-          <p:cNvPr id="5" name="Link nguon"/>
+          <p:cNvPr id="5" name="Link ung_vien c"/>
           <p:cNvSpPr/>
           <p:nvPr/>
         </p:nvSpPr>
         <p:spPr>
-          <a:xfrm flipV="1">
-            <a:off x="3383280" y="2862072"/>
-            <a:ext cx="868680" cy="2139696"/>
+          <a:xfrm>
+            <a:off x="3794760" y="2313432"/>
+            <a:ext cx="457200" cy="0"/>
           </a:xfrm>
           <a:prstGeom prst="line">
             <a:avLst/>
@@ -11931,14 +11931,86 @@
       </p:sp>
       <p:sp>
         <p:nvSpPr>
-          <p:cNvPr id="6" name="Link vong_tuyen"/>
+          <p:cNvPr id="6" name="Cardinality 1"/>
+          <p:cNvSpPr txBox="1"/>
+          <p:nvPr/>
+        </p:nvSpPr>
+        <p:spPr>
+          <a:xfrm>
+            <a:off x="3419856" y="1705356"/>
+            <a:ext cx="201168" cy="201168"/>
+          </a:xfrm>
+          <a:prstGeom prst="rect">
+            <a:avLst/>
+          </a:prstGeom>
+          <a:noFill/>
+          <a:ln/>
+        </p:spPr>
+        <p:txBody>
+          <a:bodyPr wrap="square" lIns="0" tIns="0" rIns="0" bIns="0" rtlCol="0" anchor="ctr"/>
+          <a:lstStyle/>
+          <a:p>
+            <a:pPr algn="ctr" indent="0" marL="0">
+              <a:buNone/>
+            </a:pPr>
+            <a:r>
+              <a:rPr lang="en-US" sz="1300" b="1" dirty="0">
+                <a:solidFill>
+                  <a:schemeClr val="tx2"/>
+                </a:solidFill>
+              </a:rPr>
+              <a:t>1</a:t>
+            </a:r>
+            <a:endParaRPr lang="en-US" sz="1300" dirty="0"/>
+          </a:p>
+        </p:txBody>
+      </p:sp>
+      <p:sp>
+        <p:nvSpPr>
+          <p:cNvPr id="7" name="Cardinality n"/>
+          <p:cNvSpPr txBox="1"/>
+          <p:nvPr/>
+        </p:nvSpPr>
+        <p:spPr>
+          <a:xfrm>
+            <a:off x="4023360" y="2084832"/>
+            <a:ext cx="201168" cy="201168"/>
+          </a:xfrm>
+          <a:prstGeom prst="rect">
+            <a:avLst/>
+          </a:prstGeom>
+          <a:noFill/>
+          <a:ln/>
+        </p:spPr>
+        <p:txBody>
+          <a:bodyPr wrap="square" lIns="0" tIns="0" rIns="0" bIns="0" rtlCol="0" anchor="ctr"/>
+          <a:lstStyle/>
+          <a:p>
+            <a:pPr algn="ctr" indent="0" marL="0">
+              <a:buNone/>
+            </a:pPr>
+            <a:r>
+              <a:rPr lang="en-US" sz="1300" b="1" dirty="0">
+                <a:solidFill>
+                  <a:schemeClr val="tx2"/>
+                </a:solidFill>
+              </a:rPr>
+              <a:t>n</a:t>
+            </a:r>
+            <a:endParaRPr lang="en-US" sz="1300" dirty="0"/>
+          </a:p>
+        </p:txBody>
+      </p:sp>
+      <p:sp>
+        <p:nvSpPr>
+          <p:cNvPr id="8" name="Link vi_tri a"/>
           <p:cNvSpPr/>
           <p:nvPr/>
         </p:nvSpPr>
         <p:spPr>
-          <a:xfrm flipV="1">
-            <a:off x="7818120" y="2080260"/>
-            <a:ext cx="987552" cy="1056132"/>
+          <a:xfrm>
+            <a:off x="3383280" y="3625596"/>
+            <a:ext cx="274320" cy="0"/>
           </a:xfrm>
           <a:prstGeom prst="line">
             <a:avLst/>
@@ -11954,14 +12026,14 @@
       </p:sp>
       <p:sp>
         <p:nvSpPr>
-          <p:cNvPr id="7" name="Link trang_thai"/>
+          <p:cNvPr id="9" name="Link vi_tri b"/>
           <p:cNvSpPr/>
           <p:nvPr/>
         </p:nvSpPr>
         <p:spPr>
           <a:xfrm>
-            <a:off x="7818120" y="3410712"/>
-            <a:ext cx="987552" cy="9144"/>
+            <a:off x="3657600" y="2587752"/>
+            <a:ext cx="0" cy="1037844"/>
           </a:xfrm>
           <a:prstGeom prst="line">
             <a:avLst/>
@@ -11977,7 +12049,525 @@
       </p:sp>
       <p:sp>
         <p:nvSpPr>
-          <p:cNvPr id="8" name="ung_vien box"/>
+          <p:cNvPr id="10" name="Link vi_tri c"/>
+          <p:cNvSpPr/>
+          <p:nvPr/>
+        </p:nvSpPr>
+        <p:spPr>
+          <a:xfrm>
+            <a:off x="3657600" y="2587752"/>
+            <a:ext cx="594360" cy="0"/>
+          </a:xfrm>
+          <a:prstGeom prst="line">
+            <a:avLst/>
+          </a:prstGeom>
+          <a:noFill/>
+          <a:ln w="19050">
+            <a:solidFill>
+              <a:schemeClr val="accent4"/>
+            </a:solidFill>
+            <a:prstDash val="solid"/>
+          </a:ln>
+        </p:spPr>
+      </p:sp>
+      <p:sp>
+        <p:nvSpPr>
+          <p:cNvPr id="11" name="Cardinality 1"/>
+          <p:cNvSpPr txBox="1"/>
+          <p:nvPr/>
+        </p:nvSpPr>
+        <p:spPr>
+          <a:xfrm>
+            <a:off x="3419856" y="3396996"/>
+            <a:ext cx="201168" cy="201168"/>
+          </a:xfrm>
+          <a:prstGeom prst="rect">
+            <a:avLst/>
+          </a:prstGeom>
+          <a:noFill/>
+          <a:ln/>
+        </p:spPr>
+        <p:txBody>
+          <a:bodyPr wrap="square" lIns="0" tIns="0" rIns="0" bIns="0" rtlCol="0" anchor="ctr"/>
+          <a:lstStyle/>
+          <a:p>
+            <a:pPr algn="ctr" indent="0" marL="0">
+              <a:buNone/>
+            </a:pPr>
+            <a:r>
+              <a:rPr lang="en-US" sz="1300" b="1" dirty="0">
+                <a:solidFill>
+                  <a:schemeClr val="tx2"/>
+                </a:solidFill>
+              </a:rPr>
+              <a:t>1</a:t>
+            </a:r>
+            <a:endParaRPr lang="en-US" sz="1300" dirty="0"/>
+          </a:p>
+        </p:txBody>
+      </p:sp>
+      <p:sp>
+        <p:nvSpPr>
+          <p:cNvPr id="12" name="Cardinality n"/>
+          <p:cNvSpPr txBox="1"/>
+          <p:nvPr/>
+        </p:nvSpPr>
+        <p:spPr>
+          <a:xfrm>
+            <a:off x="4023360" y="2359152"/>
+            <a:ext cx="201168" cy="201168"/>
+          </a:xfrm>
+          <a:prstGeom prst="rect">
+            <a:avLst/>
+          </a:prstGeom>
+          <a:noFill/>
+          <a:ln/>
+        </p:spPr>
+        <p:txBody>
+          <a:bodyPr wrap="square" lIns="0" tIns="0" rIns="0" bIns="0" rtlCol="0" anchor="ctr"/>
+          <a:lstStyle/>
+          <a:p>
+            <a:pPr algn="ctr" indent="0" marL="0">
+              <a:buNone/>
+            </a:pPr>
+            <a:r>
+              <a:rPr lang="en-US" sz="1300" b="1" dirty="0">
+                <a:solidFill>
+                  <a:schemeClr val="tx2"/>
+                </a:solidFill>
+              </a:rPr>
+              <a:t>n</a:t>
+            </a:r>
+            <a:endParaRPr lang="en-US" sz="1300" dirty="0"/>
+          </a:p>
+        </p:txBody>
+      </p:sp>
+      <p:sp>
+        <p:nvSpPr>
+          <p:cNvPr id="13" name="Link nguon a"/>
+          <p:cNvSpPr/>
+          <p:nvPr/>
+        </p:nvSpPr>
+        <p:spPr>
+          <a:xfrm>
+            <a:off x="3383280" y="5070348"/>
+            <a:ext cx="548640" cy="0"/>
+          </a:xfrm>
+          <a:prstGeom prst="line">
+            <a:avLst/>
+          </a:prstGeom>
+          <a:noFill/>
+          <a:ln w="19050">
+            <a:solidFill>
+              <a:schemeClr val="accent4"/>
+            </a:solidFill>
+            <a:prstDash val="solid"/>
+          </a:ln>
+        </p:spPr>
+      </p:sp>
+      <p:sp>
+        <p:nvSpPr>
+          <p:cNvPr id="14" name="Link nguon b"/>
+          <p:cNvSpPr/>
+          <p:nvPr/>
+        </p:nvSpPr>
+        <p:spPr>
+          <a:xfrm>
+            <a:off x="3931920" y="2862072"/>
+            <a:ext cx="0" cy="2208276"/>
+          </a:xfrm>
+          <a:prstGeom prst="line">
+            <a:avLst/>
+          </a:prstGeom>
+          <a:noFill/>
+          <a:ln w="19050">
+            <a:solidFill>
+              <a:schemeClr val="accent4"/>
+            </a:solidFill>
+            <a:prstDash val="solid"/>
+          </a:ln>
+        </p:spPr>
+      </p:sp>
+      <p:sp>
+        <p:nvSpPr>
+          <p:cNvPr id="15" name="Link nguon c"/>
+          <p:cNvSpPr/>
+          <p:nvPr/>
+        </p:nvSpPr>
+        <p:spPr>
+          <a:xfrm>
+            <a:off x="3931920" y="2862072"/>
+            <a:ext cx="320040" cy="0"/>
+          </a:xfrm>
+          <a:prstGeom prst="line">
+            <a:avLst/>
+          </a:prstGeom>
+          <a:noFill/>
+          <a:ln w="19050">
+            <a:solidFill>
+              <a:schemeClr val="accent4"/>
+            </a:solidFill>
+            <a:prstDash val="solid"/>
+          </a:ln>
+        </p:spPr>
+      </p:sp>
+      <p:sp>
+        <p:nvSpPr>
+          <p:cNvPr id="16" name="Cardinality 1"/>
+          <p:cNvSpPr txBox="1"/>
+          <p:nvPr/>
+        </p:nvSpPr>
+        <p:spPr>
+          <a:xfrm>
+            <a:off x="3419856" y="4841748"/>
+            <a:ext cx="201168" cy="201168"/>
+          </a:xfrm>
+          <a:prstGeom prst="rect">
+            <a:avLst/>
+          </a:prstGeom>
+          <a:noFill/>
+          <a:ln/>
+        </p:spPr>
+        <p:txBody>
+          <a:bodyPr wrap="square" lIns="0" tIns="0" rIns="0" bIns="0" rtlCol="0" anchor="ctr"/>
+          <a:lstStyle/>
+          <a:p>
+            <a:pPr algn="ctr" indent="0" marL="0">
+              <a:buNone/>
+            </a:pPr>
+            <a:r>
+              <a:rPr lang="en-US" sz="1300" b="1" dirty="0">
+                <a:solidFill>
+                  <a:schemeClr val="tx2"/>
+                </a:solidFill>
+              </a:rPr>
+              <a:t>1</a:t>
+            </a:r>
+            <a:endParaRPr lang="en-US" sz="1300" dirty="0"/>
+          </a:p>
+        </p:txBody>
+      </p:sp>
+      <p:sp>
+        <p:nvSpPr>
+          <p:cNvPr id="17" name="Cardinality n"/>
+          <p:cNvSpPr txBox="1"/>
+          <p:nvPr/>
+        </p:nvSpPr>
+        <p:spPr>
+          <a:xfrm>
+            <a:off x="4023360" y="2633472"/>
+            <a:ext cx="201168" cy="201168"/>
+          </a:xfrm>
+          <a:prstGeom prst="rect">
+            <a:avLst/>
+          </a:prstGeom>
+          <a:noFill/>
+          <a:ln/>
+        </p:spPr>
+        <p:txBody>
+          <a:bodyPr wrap="square" lIns="0" tIns="0" rIns="0" bIns="0" rtlCol="0" anchor="ctr"/>
+          <a:lstStyle/>
+          <a:p>
+            <a:pPr algn="ctr" indent="0" marL="0">
+              <a:buNone/>
+            </a:pPr>
+            <a:r>
+              <a:rPr lang="en-US" sz="1300" b="1" dirty="0">
+                <a:solidFill>
+                  <a:schemeClr val="tx2"/>
+                </a:solidFill>
+              </a:rPr>
+              <a:t>n</a:t>
+            </a:r>
+            <a:endParaRPr lang="en-US" sz="1300" dirty="0"/>
+          </a:p>
+        </p:txBody>
+      </p:sp>
+      <p:sp>
+        <p:nvSpPr>
+          <p:cNvPr id="18" name="Link vong_tuyen a"/>
+          <p:cNvSpPr/>
+          <p:nvPr/>
+        </p:nvSpPr>
+        <p:spPr>
+          <a:xfrm>
+            <a:off x="7818120" y="3136392"/>
+            <a:ext cx="457200" cy="0"/>
+          </a:xfrm>
+          <a:prstGeom prst="line">
+            <a:avLst/>
+          </a:prstGeom>
+          <a:noFill/>
+          <a:ln w="19050">
+            <a:solidFill>
+              <a:schemeClr val="accent4"/>
+            </a:solidFill>
+            <a:prstDash val="solid"/>
+          </a:ln>
+        </p:spPr>
+      </p:sp>
+      <p:sp>
+        <p:nvSpPr>
+          <p:cNvPr id="19" name="Link vong_tuyen b"/>
+          <p:cNvSpPr/>
+          <p:nvPr/>
+        </p:nvSpPr>
+        <p:spPr>
+          <a:xfrm>
+            <a:off x="8275320" y="2025396"/>
+            <a:ext cx="0" cy="1110996"/>
+          </a:xfrm>
+          <a:prstGeom prst="line">
+            <a:avLst/>
+          </a:prstGeom>
+          <a:noFill/>
+          <a:ln w="19050">
+            <a:solidFill>
+              <a:schemeClr val="accent4"/>
+            </a:solidFill>
+            <a:prstDash val="solid"/>
+          </a:ln>
+        </p:spPr>
+      </p:sp>
+      <p:sp>
+        <p:nvSpPr>
+          <p:cNvPr id="20" name="Link vong_tuyen c"/>
+          <p:cNvSpPr/>
+          <p:nvPr/>
+        </p:nvSpPr>
+        <p:spPr>
+          <a:xfrm>
+            <a:off x="8275320" y="2025396"/>
+            <a:ext cx="530352" cy="0"/>
+          </a:xfrm>
+          <a:prstGeom prst="line">
+            <a:avLst/>
+          </a:prstGeom>
+          <a:noFill/>
+          <a:ln w="19050">
+            <a:solidFill>
+              <a:schemeClr val="accent4"/>
+            </a:solidFill>
+            <a:prstDash val="solid"/>
+          </a:ln>
+        </p:spPr>
+      </p:sp>
+      <p:sp>
+        <p:nvSpPr>
+          <p:cNvPr id="21" name="Cardinality n"/>
+          <p:cNvSpPr txBox="1"/>
+          <p:nvPr/>
+        </p:nvSpPr>
+        <p:spPr>
+          <a:xfrm>
+            <a:off x="7863840" y="2907792"/>
+            <a:ext cx="201168" cy="201168"/>
+          </a:xfrm>
+          <a:prstGeom prst="rect">
+            <a:avLst/>
+          </a:prstGeom>
+          <a:noFill/>
+          <a:ln/>
+        </p:spPr>
+        <p:txBody>
+          <a:bodyPr wrap="square" lIns="0" tIns="0" rIns="0" bIns="0" rtlCol="0" anchor="ctr"/>
+          <a:lstStyle/>
+          <a:p>
+            <a:pPr algn="ctr" indent="0" marL="0">
+              <a:buNone/>
+            </a:pPr>
+            <a:r>
+              <a:rPr lang="en-US" sz="1300" b="1" dirty="0">
+                <a:solidFill>
+                  <a:schemeClr val="tx2"/>
+                </a:solidFill>
+              </a:rPr>
+              <a:t>n</a:t>
+            </a:r>
+            <a:endParaRPr lang="en-US" sz="1300" dirty="0"/>
+          </a:p>
+        </p:txBody>
+      </p:sp>
+      <p:sp>
+        <p:nvSpPr>
+          <p:cNvPr id="22" name="Cardinality 1"/>
+          <p:cNvSpPr txBox="1"/>
+          <p:nvPr/>
+        </p:nvSpPr>
+        <p:spPr>
+          <a:xfrm>
+            <a:off x="8567928" y="1796796"/>
+            <a:ext cx="201168" cy="201168"/>
+          </a:xfrm>
+          <a:prstGeom prst="rect">
+            <a:avLst/>
+          </a:prstGeom>
+          <a:noFill/>
+          <a:ln/>
+        </p:spPr>
+        <p:txBody>
+          <a:bodyPr wrap="square" lIns="0" tIns="0" rIns="0" bIns="0" rtlCol="0" anchor="ctr"/>
+          <a:lstStyle/>
+          <a:p>
+            <a:pPr algn="ctr" indent="0" marL="0">
+              <a:buNone/>
+            </a:pPr>
+            <a:r>
+              <a:rPr lang="en-US" sz="1300" b="1" dirty="0">
+                <a:solidFill>
+                  <a:schemeClr val="tx2"/>
+                </a:solidFill>
+              </a:rPr>
+              <a:t>1</a:t>
+            </a:r>
+            <a:endParaRPr lang="en-US" sz="1300" dirty="0"/>
+          </a:p>
+        </p:txBody>
+      </p:sp>
+      <p:sp>
+        <p:nvSpPr>
+          <p:cNvPr id="23" name="Link trang_thai a"/>
+          <p:cNvSpPr/>
+          <p:nvPr/>
+        </p:nvSpPr>
+        <p:spPr>
+          <a:xfrm>
+            <a:off x="7818120" y="3410712"/>
+            <a:ext cx="685800" cy="0"/>
+          </a:xfrm>
+          <a:prstGeom prst="line">
+            <a:avLst/>
+          </a:prstGeom>
+          <a:noFill/>
+          <a:ln w="19050">
+            <a:solidFill>
+              <a:schemeClr val="accent4"/>
+            </a:solidFill>
+            <a:prstDash val="solid"/>
+          </a:ln>
+        </p:spPr>
+      </p:sp>
+      <p:sp>
+        <p:nvSpPr>
+          <p:cNvPr id="24" name="Link trang_thai b"/>
+          <p:cNvSpPr/>
+          <p:nvPr/>
+        </p:nvSpPr>
+        <p:spPr>
+          <a:xfrm>
+            <a:off x="8503920" y="3410712"/>
+            <a:ext cx="0" cy="77724"/>
+          </a:xfrm>
+          <a:prstGeom prst="line">
+            <a:avLst/>
+          </a:prstGeom>
+          <a:noFill/>
+          <a:ln w="19050">
+            <a:solidFill>
+              <a:schemeClr val="accent4"/>
+            </a:solidFill>
+            <a:prstDash val="solid"/>
+          </a:ln>
+        </p:spPr>
+      </p:sp>
+      <p:sp>
+        <p:nvSpPr>
+          <p:cNvPr id="25" name="Link trang_thai c"/>
+          <p:cNvSpPr/>
+          <p:nvPr/>
+        </p:nvSpPr>
+        <p:spPr>
+          <a:xfrm>
+            <a:off x="8503920" y="3488436"/>
+            <a:ext cx="301752" cy="0"/>
+          </a:xfrm>
+          <a:prstGeom prst="line">
+            <a:avLst/>
+          </a:prstGeom>
+          <a:noFill/>
+          <a:ln w="19050">
+            <a:solidFill>
+              <a:schemeClr val="accent4"/>
+            </a:solidFill>
+            <a:prstDash val="solid"/>
+          </a:ln>
+        </p:spPr>
+      </p:sp>
+      <p:sp>
+        <p:nvSpPr>
+          <p:cNvPr id="26" name="Cardinality n"/>
+          <p:cNvSpPr txBox="1"/>
+          <p:nvPr/>
+        </p:nvSpPr>
+        <p:spPr>
+          <a:xfrm>
+            <a:off x="7863840" y="3182112"/>
+            <a:ext cx="201168" cy="201168"/>
+          </a:xfrm>
+          <a:prstGeom prst="rect">
+            <a:avLst/>
+          </a:prstGeom>
+          <a:noFill/>
+          <a:ln/>
+        </p:spPr>
+        <p:txBody>
+          <a:bodyPr wrap="square" lIns="0" tIns="0" rIns="0" bIns="0" rtlCol="0" anchor="ctr"/>
+          <a:lstStyle/>
+          <a:p>
+            <a:pPr algn="ctr" indent="0" marL="0">
+              <a:buNone/>
+            </a:pPr>
+            <a:r>
+              <a:rPr lang="en-US" sz="1300" b="1" dirty="0">
+                <a:solidFill>
+                  <a:schemeClr val="tx2"/>
+                </a:solidFill>
+              </a:rPr>
+              <a:t>n</a:t>
+            </a:r>
+            <a:endParaRPr lang="en-US" sz="1300" dirty="0"/>
+          </a:p>
+        </p:txBody>
+      </p:sp>
+      <p:sp>
+        <p:nvSpPr>
+          <p:cNvPr id="27" name="Cardinality 1"/>
+          <p:cNvSpPr txBox="1"/>
+          <p:nvPr/>
+        </p:nvSpPr>
+        <p:spPr>
+          <a:xfrm>
+            <a:off x="8567928" y="3259836"/>
+            <a:ext cx="201168" cy="201168"/>
+          </a:xfrm>
+          <a:prstGeom prst="rect">
+            <a:avLst/>
+          </a:prstGeom>
+          <a:noFill/>
+          <a:ln/>
+        </p:spPr>
+        <p:txBody>
+          <a:bodyPr wrap="square" lIns="0" tIns="0" rIns="0" bIns="0" rtlCol="0" anchor="ctr"/>
+          <a:lstStyle/>
+          <a:p>
+            <a:pPr algn="ctr" indent="0" marL="0">
+              <a:buNone/>
+            </a:pPr>
+            <a:r>
+              <a:rPr lang="en-US" sz="1300" b="1" dirty="0">
+                <a:solidFill>
+                  <a:schemeClr val="tx2"/>
+                </a:solidFill>
+              </a:rPr>
+              <a:t>1</a:t>
+            </a:r>
+            <a:endParaRPr lang="en-US" sz="1300" dirty="0"/>
+          </a:p>
+        </p:txBody>
+      </p:sp>
+      <p:sp>
+        <p:nvSpPr>
+          <p:cNvPr id="28" name="ung_vien box"/>
           <p:cNvSpPr/>
           <p:nvPr/>
         </p:nvSpPr>
@@ -12002,7 +12592,7 @@
       </p:sp>
       <p:sp>
         <p:nvSpPr>
-          <p:cNvPr id="9" name="ung_vien header"/>
+          <p:cNvPr id="29" name="ung_vien header"/>
           <p:cNvSpPr txBox="1"/>
           <p:nvPr/>
         </p:nvSpPr>
@@ -12043,7 +12633,7 @@
       </p:sp>
       <p:sp>
         <p:nvSpPr>
-          <p:cNvPr id="10" name="ung_vien row 1"/>
+          <p:cNvPr id="30" name="ung_vien row 1"/>
           <p:cNvSpPr txBox="1"/>
           <p:nvPr/>
         </p:nvSpPr>
@@ -12093,7 +12683,7 @@
       </p:sp>
       <p:sp>
         <p:nvSpPr>
-          <p:cNvPr id="11" name="ung_vien row 2"/>
+          <p:cNvPr id="31" name="ung_vien row 2"/>
           <p:cNvSpPr txBox="1"/>
           <p:nvPr/>
         </p:nvSpPr>
@@ -12132,7 +12722,7 @@
       </p:sp>
       <p:sp>
         <p:nvSpPr>
-          <p:cNvPr id="12" name="ung_vien row 3"/>
+          <p:cNvPr id="32" name="ung_vien row 3"/>
           <p:cNvSpPr txBox="1"/>
           <p:nvPr/>
         </p:nvSpPr>
@@ -12171,7 +12761,7 @@
       </p:sp>
       <p:sp>
         <p:nvSpPr>
-          <p:cNvPr id="13" name="ung_vien row 4"/>
+          <p:cNvPr id="33" name="ung_vien row 4"/>
           <p:cNvSpPr txBox="1"/>
           <p:nvPr/>
         </p:nvSpPr>
@@ -12210,7 +12800,7 @@
       </p:sp>
       <p:sp>
         <p:nvSpPr>
-          <p:cNvPr id="14" name="vi_tri box"/>
+          <p:cNvPr id="34" name="vi_tri box"/>
           <p:cNvSpPr/>
           <p:nvPr/>
         </p:nvSpPr>
@@ -12235,7 +12825,7 @@
       </p:sp>
       <p:sp>
         <p:nvSpPr>
-          <p:cNvPr id="15" name="vi_tri header"/>
+          <p:cNvPr id="35" name="vi_tri header"/>
           <p:cNvSpPr txBox="1"/>
           <p:nvPr/>
         </p:nvSpPr>
@@ -12276,7 +12866,7 @@
       </p:sp>
       <p:sp>
         <p:nvSpPr>
-          <p:cNvPr id="16" name="vi_tri row 1"/>
+          <p:cNvPr id="36" name="vi_tri row 1"/>
           <p:cNvSpPr txBox="1"/>
           <p:nvPr/>
         </p:nvSpPr>
@@ -12326,7 +12916,7 @@
       </p:sp>
       <p:sp>
         <p:nvSpPr>
-          <p:cNvPr id="17" name="vi_tri row 2"/>
+          <p:cNvPr id="37" name="vi_tri row 2"/>
           <p:cNvSpPr txBox="1"/>
           <p:nvPr/>
         </p:nvSpPr>
@@ -12365,7 +12955,7 @@
       </p:sp>
       <p:sp>
         <p:nvSpPr>
-          <p:cNvPr id="18" name="vi_tri row 3"/>
+          <p:cNvPr id="38" name="vi_tri row 3"/>
           <p:cNvSpPr txBox="1"/>
           <p:nvPr/>
         </p:nvSpPr>
@@ -12404,7 +12994,7 @@
       </p:sp>
       <p:sp>
         <p:nvSpPr>
-          <p:cNvPr id="19" name="nguon box"/>
+          <p:cNvPr id="39" name="nguon box"/>
           <p:cNvSpPr/>
           <p:nvPr/>
         </p:nvSpPr>
@@ -12429,7 +13019,7 @@
       </p:sp>
       <p:sp>
         <p:nvSpPr>
-          <p:cNvPr id="20" name="nguon header"/>
+          <p:cNvPr id="40" name="nguon header"/>
           <p:cNvSpPr txBox="1"/>
           <p:nvPr/>
         </p:nvSpPr>
@@ -12470,7 +13060,7 @@
       </p:sp>
       <p:sp>
         <p:nvSpPr>
-          <p:cNvPr id="21" name="nguon row 1"/>
+          <p:cNvPr id="41" name="nguon row 1"/>
           <p:cNvSpPr txBox="1"/>
           <p:nvPr/>
         </p:nvSpPr>
@@ -12520,7 +13110,7 @@
       </p:sp>
       <p:sp>
         <p:nvSpPr>
-          <p:cNvPr id="22" name="nguon row 2"/>
+          <p:cNvPr id="42" name="nguon row 2"/>
           <p:cNvSpPr txBox="1"/>
           <p:nvPr/>
         </p:nvSpPr>
@@ -12559,7 +13149,7 @@
       </p:sp>
       <p:sp>
         <p:nvSpPr>
-          <p:cNvPr id="23" name="vong_tuyen box"/>
+          <p:cNvPr id="43" name="vong_tuyen box"/>
           <p:cNvSpPr/>
           <p:nvPr/>
         </p:nvSpPr>
@@ -12584,7 +13174,7 @@
       </p:sp>
       <p:sp>
         <p:nvSpPr>
-          <p:cNvPr id="24" name="vong_tuyen header"/>
+          <p:cNvPr id="44" name="vong_tuyen header"/>
           <p:cNvSpPr txBox="1"/>
           <p:nvPr/>
         </p:nvSpPr>
@@ -12625,7 +13215,7 @@
       </p:sp>
       <p:sp>
         <p:nvSpPr>
-          <p:cNvPr id="25" name="vong_tuyen row 1"/>
+          <p:cNvPr id="45" name="vong_tuyen row 1"/>
           <p:cNvSpPr txBox="1"/>
           <p:nvPr/>
         </p:nvSpPr>
@@ -12675,7 +13265,7 @@
       </p:sp>
       <p:sp>
         <p:nvSpPr>
-          <p:cNvPr id="26" name="vong_tuyen row 2"/>
+          <p:cNvPr id="46" name="vong_tuyen row 2"/>
           <p:cNvSpPr txBox="1"/>
           <p:nvPr/>
         </p:nvSpPr>
@@ -12714,7 +13304,7 @@
       </p:sp>
       <p:sp>
         <p:nvSpPr>
-          <p:cNvPr id="27" name="vong_tuyen row 3"/>
+          <p:cNvPr id="47" name="vong_tuyen row 3"/>
           <p:cNvSpPr txBox="1"/>
           <p:nvPr/>
         </p:nvSpPr>
@@ -12753,7 +13343,7 @@
       </p:sp>
       <p:sp>
         <p:nvSpPr>
-          <p:cNvPr id="28" name="trang_thai box"/>
+          <p:cNvPr id="48" name="trang_thai box"/>
           <p:cNvSpPr/>
           <p:nvPr/>
         </p:nvSpPr>
@@ -12778,7 +13368,7 @@
       </p:sp>
       <p:sp>
         <p:nvSpPr>
-          <p:cNvPr id="29" name="trang_thai header"/>
+          <p:cNvPr id="49" name="trang_thai header"/>
           <p:cNvSpPr txBox="1"/>
           <p:nvPr/>
         </p:nvSpPr>
@@ -12819,7 +13409,7 @@
       </p:sp>
       <p:sp>
         <p:nvSpPr>
-          <p:cNvPr id="30" name="trang_thai row 1"/>
+          <p:cNvPr id="50" name="trang_thai row 1"/>
           <p:cNvSpPr txBox="1"/>
           <p:nvPr/>
         </p:nvSpPr>
@@ -12869,7 +13459,7 @@
       </p:sp>
       <p:sp>
         <p:nvSpPr>
-          <p:cNvPr id="31" name="trang_thai row 2"/>
+          <p:cNvPr id="51" name="trang_thai row 2"/>
           <p:cNvSpPr txBox="1"/>
           <p:nvPr/>
         </p:nvSpPr>
@@ -12908,7 +13498,7 @@
       </p:sp>
       <p:sp>
         <p:nvSpPr>
-          <p:cNvPr id="32" name="ho_so_ung_tuyen box"/>
+          <p:cNvPr id="52" name="ho_so_ung_tuyen box"/>
           <p:cNvSpPr/>
           <p:nvPr/>
         </p:nvSpPr>
@@ -12933,7 +13523,7 @@
       </p:sp>
       <p:sp>
         <p:nvSpPr>
-          <p:cNvPr id="33" name="ho_so_ung_tuyen header"/>
+          <p:cNvPr id="53" name="ho_so_ung_tuyen header"/>
           <p:cNvSpPr txBox="1"/>
           <p:nvPr/>
         </p:nvSpPr>
@@ -12974,7 +13564,7 @@
       </p:sp>
       <p:sp>
         <p:nvSpPr>
-          <p:cNvPr id="34" name="ho_so_ung_tuyen row 1"/>
+          <p:cNvPr id="54" name="ho_so_ung_tuyen row 1"/>
           <p:cNvSpPr txBox="1"/>
           <p:nvPr/>
         </p:nvSpPr>
@@ -13024,7 +13614,7 @@
       </p:sp>
       <p:sp>
         <p:nvSpPr>
-          <p:cNvPr id="35" name="ho_so_ung_tuyen row 2"/>
+          <p:cNvPr id="55" name="ho_so_ung_tuyen row 2"/>
           <p:cNvSpPr txBox="1"/>
           <p:nvPr/>
         </p:nvSpPr>
@@ -13074,7 +13664,7 @@
       </p:sp>
       <p:sp>
         <p:nvSpPr>
-          <p:cNvPr id="36" name="ho_so_ung_tuyen row 3"/>
+          <p:cNvPr id="56" name="ho_so_ung_tuyen row 3"/>
           <p:cNvSpPr txBox="1"/>
           <p:nvPr/>
         </p:nvSpPr>
@@ -13124,7 +13714,7 @@
       </p:sp>
       <p:sp>
         <p:nvSpPr>
-          <p:cNvPr id="37" name="ho_so_ung_tuyen row 4"/>
+          <p:cNvPr id="57" name="ho_so_ung_tuyen row 4"/>
           <p:cNvSpPr txBox="1"/>
           <p:nvPr/>
         </p:nvSpPr>
@@ -13174,7 +13764,7 @@
       </p:sp>
       <p:sp>
         <p:nvSpPr>
-          <p:cNvPr id="38" name="ho_so_ung_tuyen row 5"/>
+          <p:cNvPr id="58" name="ho_so_ung_tuyen row 5"/>
           <p:cNvSpPr txBox="1"/>
           <p:nvPr/>
         </p:nvSpPr>
@@ -13224,7 +13814,7 @@
       </p:sp>
       <p:sp>
         <p:nvSpPr>
-          <p:cNvPr id="39" name="ho_so_ung_tuyen row 6"/>
+          <p:cNvPr id="59" name="ho_so_ung_tuyen row 6"/>
           <p:cNvSpPr txBox="1"/>
           <p:nvPr/>
         </p:nvSpPr>
@@ -13274,7 +13864,7 @@
       </p:sp>
       <p:sp>
         <p:nvSpPr>
-          <p:cNvPr id="40" name="ho_so_ung_tuyen row 7"/>
+          <p:cNvPr id="60" name="ho_so_ung_tuyen row 7"/>
           <p:cNvSpPr txBox="1"/>
           <p:nvPr/>
         </p:nvSpPr>
@@ -13313,7 +13903,7 @@
       </p:sp>
       <p:sp>
         <p:nvSpPr>
-          <p:cNvPr id="41" name="ho_so_ung_tuyen row 8"/>
+          <p:cNvPr id="61" name="ho_so_ung_tuyen row 8"/>
           <p:cNvSpPr txBox="1"/>
           <p:nvPr/>
         </p:nvSpPr>
@@ -13352,7 +13942,7 @@
       </p:sp>
       <p:sp>
         <p:nvSpPr>
-          <p:cNvPr id="42" name="Main table notes"/>
+          <p:cNvPr id="62" name="Main table notes"/>
           <p:cNvSpPr txBox="1"/>
           <p:nvPr/>
         </p:nvSpPr>
@@ -13410,7 +14000,7 @@
       </p:sp>
       <p:sp>
         <p:nvSpPr>
-          <p:cNvPr id="43" name="Legend card"/>
+          <p:cNvPr id="63" name="Legend card"/>
           <p:cNvSpPr/>
           <p:nvPr/>
         </p:nvSpPr>
@@ -13437,7 +14027,7 @@
       </p:sp>
       <p:sp>
         <p:nvSpPr>
-          <p:cNvPr id="44" name="Legend text"/>
+          <p:cNvPr id="64" name="Legend text"/>
           <p:cNvSpPr txBox="1"/>
           <p:nvPr/>
         </p:nvSpPr>
@@ -13518,7 +14108,7 @@
                   <a:schemeClr val="tx2"/>
                 </a:solidFill>
               </a:rPr>
-              <a:t>Đường nối</a:t>
+              <a:t>1 — n</a:t>
             </a:r>
             <a:r>
               <a:rPr lang="en-US" sz="1400" dirty="0">

</xml_diff>